<commit_message>
Worksheet: Persian labels for critic types
Co-Authored-By: Claude Sonnet 5.5 <noreply@anthropic.com>
Claude-Session: https://claude.ai/code/session_018eMZXBKLzeFCo2o1NXtn4j
</commit_message>
<xml_diff>
--- a/webinar-slides/Worksheet_Self_Attack_Cycle_Map.pptx
+++ b/webinar-slides/Worksheet_Self_Attack_Cycle_Map.pptx
@@ -1519,20 +1519,23 @@
           <a:bodyPr wrap="square" lIns="0" tIns="0" rIns="0" bIns="0" rtlCol="0" anchor="t"/>
           <a:lstStyle/>
           <a:p>
-            <a:pPr algn="r" indent="0" marL="0">
-              <a:buNone/>
-            </a:pPr>
-            <a:r>
-              <a:rPr lang="en-US" altLang="en-US" sz="1000" dirty="0">
+            <a:pPr rtl="1" algn="r" indent="0" marL="0">
+              <a:lnSpc>
+                <a:spcPct val="115000"/>
+              </a:lnSpc>
+              <a:buNone/>
+            </a:pPr>
+            <a:r>
+              <a:rPr lang="fa-IR" altLang="en-US" sz="1200" dirty="0">
                 <a:solidFill>
                   <a:schemeClr val="accent5"/>
                 </a:solidFill>
                 <a:latin typeface="Arial" pitchFamily="34" charset="0"/>
                 <a:cs typeface="Arial" pitchFamily="34" charset="178"/>
               </a:rPr>
-              <a:t>Worrier · Not good enough · Hated self · Teamster · Non-feeler · Not good enough for others</a:t>
-            </a:r>
-            <a:endParaRPr lang="en-US" sz="1000" dirty="0"/>
+              <a:t>نگران · کافی نیستی · خودت مشکلی · بیشتر تلاش کن · احساس نکن · برای دیگران کافی نیستی</a:t>
+            </a:r>
+            <a:endParaRPr lang="fa-IR" sz="1200" dirty="0"/>
           </a:p>
         </p:txBody>
       </p:sp>

</xml_diff>

<commit_message>
Worksheet: one critic type per line
Co-Authored-By: Claude Sonnet 5.5 <noreply@anthropic.com>
Claude-Session: https://claude.ai/code/session_018eMZXBKLzeFCo2o1NXtn4j
</commit_message>
<xml_diff>
--- a/webinar-slides/Worksheet_Self_Attack_Cycle_Map.pptx
+++ b/webinar-slides/Worksheet_Self_Attack_Cycle_Map.pptx
@@ -1506,8 +1506,8 @@
         </p:nvSpPr>
         <p:spPr>
           <a:xfrm>
-            <a:off x="5175504" y="5852160"/>
-            <a:ext cx="1655064" cy="1097280"/>
+            <a:off x="5175504" y="5806440"/>
+            <a:ext cx="1655064" cy="1325880"/>
           </a:xfrm>
           <a:prstGeom prst="rect">
             <a:avLst/>
@@ -1519,9 +1519,9 @@
           <a:bodyPr wrap="square" lIns="0" tIns="0" rIns="0" bIns="0" rtlCol="0" anchor="t"/>
           <a:lstStyle/>
           <a:p>
-            <a:pPr rtl="1" algn="r" indent="0" marL="0">
+            <a:pPr algn="r" indent="0" marL="0">
               <a:lnSpc>
-                <a:spcPct val="115000"/>
+                <a:spcPct val="105000"/>
               </a:lnSpc>
               <a:buNone/>
             </a:pPr>
@@ -1533,7 +1533,102 @@
                 <a:latin typeface="Arial" pitchFamily="34" charset="0"/>
                 <a:cs typeface="Arial" pitchFamily="34" charset="178"/>
               </a:rPr>
-              <a:t>نگران · کافی نیستی · خودت مشکلی · بیشتر تلاش کن · احساس نکن · برای دیگران کافی نیستی</a:t>
+              <a:t>نگران</a:t>
+            </a:r>
+            <a:endParaRPr lang="fa-IR" sz="1200" dirty="0"/>
+          </a:p>
+          <a:p>
+            <a:pPr algn="r" indent="0" marL="0">
+              <a:lnSpc>
+                <a:spcPct val="105000"/>
+              </a:lnSpc>
+              <a:buNone/>
+            </a:pPr>
+            <a:r>
+              <a:rPr lang="fa-IR" altLang="en-US" sz="1200" dirty="0">
+                <a:solidFill>
+                  <a:schemeClr val="accent5"/>
+                </a:solidFill>
+                <a:latin typeface="Arial" pitchFamily="34" charset="0"/>
+                <a:cs typeface="Arial" pitchFamily="34" charset="178"/>
+              </a:rPr>
+              <a:t>کافی نیستی</a:t>
+            </a:r>
+            <a:endParaRPr lang="fa-IR" sz="1200" dirty="0"/>
+          </a:p>
+          <a:p>
+            <a:pPr algn="r" indent="0" marL="0">
+              <a:lnSpc>
+                <a:spcPct val="105000"/>
+              </a:lnSpc>
+              <a:buNone/>
+            </a:pPr>
+            <a:r>
+              <a:rPr lang="fa-IR" altLang="en-US" sz="1200" dirty="0">
+                <a:solidFill>
+                  <a:schemeClr val="accent5"/>
+                </a:solidFill>
+                <a:latin typeface="Arial" pitchFamily="34" charset="0"/>
+                <a:cs typeface="Arial" pitchFamily="34" charset="178"/>
+              </a:rPr>
+              <a:t>خودت مشکلی</a:t>
+            </a:r>
+            <a:endParaRPr lang="fa-IR" sz="1200" dirty="0"/>
+          </a:p>
+          <a:p>
+            <a:pPr algn="r" indent="0" marL="0">
+              <a:lnSpc>
+                <a:spcPct val="105000"/>
+              </a:lnSpc>
+              <a:buNone/>
+            </a:pPr>
+            <a:r>
+              <a:rPr lang="fa-IR" altLang="en-US" sz="1200" dirty="0">
+                <a:solidFill>
+                  <a:schemeClr val="accent5"/>
+                </a:solidFill>
+                <a:latin typeface="Arial" pitchFamily="34" charset="0"/>
+                <a:cs typeface="Arial" pitchFamily="34" charset="178"/>
+              </a:rPr>
+              <a:t>بیشتر تلاش کن</a:t>
+            </a:r>
+            <a:endParaRPr lang="fa-IR" sz="1200" dirty="0"/>
+          </a:p>
+          <a:p>
+            <a:pPr algn="r" indent="0" marL="0">
+              <a:lnSpc>
+                <a:spcPct val="105000"/>
+              </a:lnSpc>
+              <a:buNone/>
+            </a:pPr>
+            <a:r>
+              <a:rPr lang="fa-IR" altLang="en-US" sz="1200" dirty="0">
+                <a:solidFill>
+                  <a:schemeClr val="accent5"/>
+                </a:solidFill>
+                <a:latin typeface="Arial" pitchFamily="34" charset="0"/>
+                <a:cs typeface="Arial" pitchFamily="34" charset="178"/>
+              </a:rPr>
+              <a:t>احساس نکن</a:t>
+            </a:r>
+            <a:endParaRPr lang="fa-IR" sz="1200" dirty="0"/>
+          </a:p>
+          <a:p>
+            <a:pPr algn="r" indent="0" marL="0">
+              <a:lnSpc>
+                <a:spcPct val="105000"/>
+              </a:lnSpc>
+              <a:buNone/>
+            </a:pPr>
+            <a:r>
+              <a:rPr lang="fa-IR" altLang="en-US" sz="1200" dirty="0">
+                <a:solidFill>
+                  <a:schemeClr val="accent5"/>
+                </a:solidFill>
+                <a:latin typeface="Arial" pitchFamily="34" charset="0"/>
+                <a:cs typeface="Arial" pitchFamily="34" charset="178"/>
+              </a:rPr>
+              <a:t>برای دیگران کافی نیستی</a:t>
             </a:r>
             <a:endParaRPr lang="fa-IR" sz="1200" dirty="0"/>
           </a:p>

</xml_diff>